<commit_message>
Restyle deck in bright mural palette (blue, yellow, red, pink, green)
Co-Authored-By: Claude Opus 5.5 <noreply@anthropic.com>
</commit_message>
<xml_diff>
--- a/presentation/deck_design.pptx
+++ b/presentation/deck_design.pptx
@@ -130,14 +130,14 @@
   <p:extLst>
     <p:ext uri="{521415D9-36F7-43E2-AB2F-B90AF26B5E84}">
       <p14:sectionLst xmlns:p14="http://schemas.microsoft.com/office/powerpoint/2010/main">
-        <p14:section name="Opening" id="{ff33a26a-a983-094d-17bd-e66cdd58de12}">
+        <p14:section name="Opening" id="{38701972-2da3-a51c-5fff-fe24cb21dae2}">
           <p14:sldIdLst>
             <p14:sldId id="256"/>
             <p14:sldId id="257"/>
             <p14:sldId id="258"/>
           </p14:sldIdLst>
         </p14:section>
-        <p14:section name="Task 1: Forecast" id="{1bfce69b-cb3f-f019-ec70-547c79a7bd65}">
+        <p14:section name="Task 1: Forecast" id="{f9c55cfe-71ee-de8d-cbf1-2f417961729d}">
           <p14:sldIdLst>
             <p14:sldId id="259"/>
             <p14:sldId id="260"/>
@@ -149,7 +149,7 @@
             <p14:sldId id="266"/>
           </p14:sldIdLst>
         </p14:section>
-        <p14:section name="Task 2: Allocation" id="{c32f9ece-7da7-4c25-dbc3-63f263a659dd}">
+        <p14:section name="Task 2: Allocation" id="{b72e75f8-2e85-1632-7c51-5a1acfb10625}">
           <p14:sldIdLst>
             <p14:sldId id="267"/>
             <p14:sldId id="268"/>
@@ -158,13 +158,13 @@
             <p14:sldId id="271"/>
           </p14:sldIdLst>
         </p14:section>
-        <p14:section name="Close" id="{19a28b77-0756-a63a-bb44-e87b02b1abb2}">
+        <p14:section name="Close" id="{a131e50d-f119-9a11-36d6-8ea5ed572f96}">
           <p14:sldIdLst>
             <p14:sldId id="272"/>
             <p14:sldId id="273"/>
           </p14:sldIdLst>
         </p14:section>
-        <p14:section name="Appendix" id="{b6cf51b0-a8c2-1a9a-33a6-dcc97c2d42d5}">
+        <p14:section name="Appendix" id="{91aed573-0dec-84b9-0e57-fb857afc6e2b}">
           <p14:sldIdLst>
             <p14:sldId id="274"/>
             <p14:sldId id="275"/>
@@ -2680,7 +2680,7 @@
     <p:bg>
       <p:bgPr>
         <a:solidFill>
-          <a:srgbClr val="0A3D62"/>
+          <a:srgbClr val="0F79D5"/>
         </a:solidFill>
       </p:bgPr>
     </p:bg>
@@ -2839,7 +2839,7 @@
             </a:avLst>
           </a:prstGeom>
           <a:solidFill>
-            <a:srgbClr val="E9C46A"/>
+            <a:srgbClr val="F4B223"/>
           </a:solidFill>
           <a:ln/>
         </p:spPr>
@@ -2880,7 +2880,7 @@
               <a:buNone/>
               <a:defRPr lang="en-US" sz="1800" b="1" dirty="0">
                 <a:solidFill>
-                  <a:schemeClr val="tx2"/>
+                  <a:schemeClr val="tx1"/>
                 </a:solidFill>
                 <a:latin typeface="Cambria" pitchFamily="34" charset="0"/>
                 <a:ea typeface="Cambria" pitchFamily="34" charset="-122"/>
@@ -2895,7 +2895,7 @@
             <a:r>
               <a:rPr lang="en-US" sz="1800" b="1" dirty="0">
                 <a:solidFill>
-                  <a:schemeClr val="tx2"/>
+                  <a:schemeClr val="tx1"/>
                 </a:solidFill>
                 <a:latin typeface="Cambria" pitchFamily="34" charset="0"/>
                 <a:ea typeface="Cambria" pitchFamily="34" charset="-122"/>
@@ -2919,7 +2919,7 @@
         </p:nvSpPr>
         <p:spPr>
           <a:xfrm>
-            <a:off x="11094415" y="6400800"/>
+            <a:off x="11094415" y="365760"/>
             <a:ext cx="548640" cy="274320"/>
           </a:xfrm>
           <a:prstGeom prst="rect">
@@ -2937,7 +2937,7 @@
             <a:lvl1pPr>
               <a:defRPr sz="1000">
                 <a:solidFill>
-                  <a:srgbClr val="E9C46A"/>
+                  <a:srgbClr val="FFFFFF"/>
                 </a:solidFill>
               </a:defRPr>
             </a:lvl1pPr>
@@ -3001,7 +3001,7 @@
             </a:avLst>
           </a:prstGeom>
           <a:solidFill>
-            <a:srgbClr val="EAF1F6"/>
+            <a:srgbClr val="E7F1FB"/>
           </a:solidFill>
           <a:ln/>
         </p:spPr>
@@ -3042,7 +3042,7 @@
               <a:buNone/>
               <a:defRPr lang="en-US" sz="1100" b="1" spc="150" kern="0" dirty="0">
                 <a:solidFill>
-                  <a:schemeClr val="tx2"/>
+                  <a:schemeClr val="tx1"/>
                 </a:solidFill>
               </a:defRPr>
             </a:lvl1pPr>
@@ -3054,7 +3054,7 @@
             <a:r>
               <a:rPr lang="en-US" sz="1100" b="1" spc="150" kern="0" dirty="0">
                 <a:solidFill>
-                  <a:schemeClr val="tx2"/>
+                  <a:schemeClr val="tx1"/>
                 </a:solidFill>
               </a:rPr>
               <a:t>APPENDIX</a:t>
@@ -3252,7 +3252,7 @@
     <p:bg>
       <p:bgPr>
         <a:solidFill>
-          <a:srgbClr val="0A3D62"/>
+          <a:srgbClr val="0F79D5"/>
         </a:solidFill>
       </p:bgPr>
     </p:bg>
@@ -3286,8 +3286,8 @@
         </p:blipFill>
         <p:spPr>
           <a:xfrm>
-            <a:off x="0" y="5486400"/>
-            <a:ext cx="12191695" cy="1371600"/>
+            <a:off x="8506663" y="0"/>
+            <a:ext cx="3685032" cy="6858000"/>
           </a:xfrm>
           <a:prstGeom prst="rect">
             <a:avLst/>
@@ -3305,7 +3305,7 @@
         <p:spPr>
           <a:xfrm>
             <a:off x="731520" y="1554480"/>
-            <a:ext cx="8686800" cy="1645920"/>
+            <a:ext cx="7223760" cy="1645920"/>
           </a:xfrm>
           <a:prstGeom prst="rect">
             <a:avLst/>
@@ -3352,7 +3352,7 @@
         <p:spPr>
           <a:xfrm>
             <a:off x="731520" y="3337560"/>
-            <a:ext cx="8686800" cy="548640"/>
+            <a:ext cx="7223760" cy="548640"/>
           </a:xfrm>
           <a:prstGeom prst="rect">
             <a:avLst/>
@@ -3367,7 +3367,7 @@
               <a:buNone/>
               <a:defRPr lang="en-US" sz="2000" dirty="0">
                 <a:solidFill>
-                  <a:schemeClr val="accent2"/>
+                  <a:schemeClr val="bg1"/>
                 </a:solidFill>
               </a:defRPr>
             </a:lvl1pPr>
@@ -3379,7 +3379,7 @@
             <a:r>
               <a:rPr lang="en-US" sz="2000" dirty="0">
                 <a:solidFill>
-                  <a:schemeClr val="accent2"/>
+                  <a:schemeClr val="bg1"/>
                 </a:solidFill>
               </a:rPr>
               <a:t>Subtitle: the recommendation in one line</a:t>
@@ -3399,7 +3399,7 @@
         <p:spPr>
           <a:xfrm>
             <a:off x="731520" y="4206240"/>
-            <a:ext cx="8686800" cy="731520"/>
+            <a:ext cx="7223760" cy="731520"/>
           </a:xfrm>
           <a:prstGeom prst="rect">
             <a:avLst/>
@@ -3449,7 +3449,7 @@
     <p:bg>
       <p:bgPr>
         <a:solidFill>
-          <a:srgbClr val="0A3D62"/>
+          <a:srgbClr val="0F79D5"/>
         </a:solidFill>
       </p:bgPr>
     </p:bg>
@@ -3506,7 +3506,7 @@
             <a:avLst/>
           </a:prstGeom>
           <a:solidFill>
-            <a:srgbClr val="E9C46A"/>
+            <a:srgbClr val="F4B223"/>
           </a:solidFill>
           <a:ln/>
         </p:spPr>
@@ -3547,7 +3547,7 @@
               <a:buNone/>
               <a:defRPr lang="en-US" sz="4000" b="1" dirty="0">
                 <a:solidFill>
-                  <a:schemeClr val="tx2"/>
+                  <a:schemeClr val="tx1"/>
                 </a:solidFill>
                 <a:latin typeface="Cambria" pitchFamily="34" charset="0"/>
                 <a:ea typeface="Cambria" pitchFamily="34" charset="-122"/>
@@ -3562,7 +3562,7 @@
             <a:r>
               <a:rPr lang="en-US" sz="4000" b="1" dirty="0">
                 <a:solidFill>
-                  <a:schemeClr val="tx2"/>
+                  <a:schemeClr val="tx1"/>
                 </a:solidFill>
                 <a:latin typeface="Cambria" pitchFamily="34" charset="0"/>
                 <a:ea typeface="Cambria" pitchFamily="34" charset="-122"/>
@@ -3647,7 +3647,7 @@
               <a:buNone/>
               <a:defRPr lang="en-US" sz="1800" dirty="0">
                 <a:solidFill>
-                  <a:schemeClr val="accent2"/>
+                  <a:schemeClr val="bg1"/>
                 </a:solidFill>
               </a:defRPr>
             </a:lvl1pPr>
@@ -3659,7 +3659,7 @@
             <a:r>
               <a:rPr lang="en-US" sz="1800" dirty="0">
                 <a:solidFill>
-                  <a:schemeClr val="accent2"/>
+                  <a:schemeClr val="bg1"/>
                 </a:solidFill>
               </a:rPr>
               <a:t>The question this section answers</a:t>
@@ -3670,42 +3670,6 @@
       </p:sp>
       <p:sp>
         <p:nvSpPr>
-          <p:cNvPr id="7" name="Text 1"/>
-          <p:cNvSpPr/>
-          <p:nvPr/>
-        </p:nvSpPr>
-        <p:spPr>
-          <a:xfrm>
-            <a:off x="548640" y="6400800"/>
-            <a:ext cx="5486400" cy="274320"/>
-          </a:xfrm>
-          <a:prstGeom prst="rect">
-            <a:avLst/>
-          </a:prstGeom>
-          <a:noFill/>
-          <a:ln/>
-        </p:spPr>
-        <p:txBody>
-          <a:bodyPr wrap="square" lIns="0" tIns="0" rIns="0" bIns="0" rtlCol="0" anchor="ctr"/>
-          <a:lstStyle/>
-          <a:p>
-            <a:pPr indent="0" marL="0">
-              <a:buNone/>
-            </a:pPr>
-            <a:r>
-              <a:rPr lang="en-US" sz="1000" dirty="0">
-                <a:solidFill>
-                  <a:schemeClr val="bg1"/>
-                </a:solidFill>
-              </a:rPr>
-              <a:t>UNSW ASOC x Taylor Fry Case Competition 2026</a:t>
-            </a:r>
-            <a:endParaRPr lang="en-US" sz="1000" dirty="0"/>
-          </a:p>
-        </p:txBody>
-      </p:sp>
-      <p:sp>
-        <p:nvSpPr>
           <p:cNvPr id="25" name="Slide Number Placeholder 0"/>
           <p:cNvSpPr>
             <a:spLocks noGrp="1"/>
@@ -3716,7 +3680,7 @@
         </p:nvSpPr>
         <p:spPr>
           <a:xfrm>
-            <a:off x="11094415" y="6400800"/>
+            <a:off x="11094415" y="365760"/>
             <a:ext cx="548640" cy="274320"/>
           </a:xfrm>
           <a:prstGeom prst="rect">
@@ -3734,7 +3698,7 @@
             <a:lvl1pPr>
               <a:defRPr sz="1000">
                 <a:solidFill>
-                  <a:srgbClr val="E9C46A"/>
+                  <a:srgbClr val="FFFFFF"/>
                 </a:solidFill>
               </a:defRPr>
             </a:lvl1pPr>
@@ -3798,7 +3762,7 @@
             </a:avLst>
           </a:prstGeom>
           <a:solidFill>
-            <a:srgbClr val="E9C46A"/>
+            <a:srgbClr val="F4B223"/>
           </a:solidFill>
           <a:ln/>
         </p:spPr>
@@ -3839,7 +3803,7 @@
               <a:buNone/>
               <a:defRPr lang="en-US" sz="1100" b="1" spc="150" kern="0" dirty="0">
                 <a:solidFill>
-                  <a:schemeClr val="tx2"/>
+                  <a:schemeClr val="tx1"/>
                 </a:solidFill>
               </a:defRPr>
             </a:lvl1pPr>
@@ -3851,7 +3815,7 @@
             <a:r>
               <a:rPr lang="en-US" sz="1100" b="1" spc="150" kern="0" dirty="0">
                 <a:solidFill>
-                  <a:schemeClr val="tx2"/>
+                  <a:schemeClr val="tx1"/>
                 </a:solidFill>
               </a:rPr>
               <a:t>SECTION</a:t>
@@ -4084,7 +4048,7 @@
             </a:avLst>
           </a:prstGeom>
           <a:solidFill>
-            <a:srgbClr val="E9C46A"/>
+            <a:srgbClr val="F4B223"/>
           </a:solidFill>
           <a:ln/>
         </p:spPr>
@@ -4125,7 +4089,7 @@
               <a:buNone/>
               <a:defRPr lang="en-US" sz="1100" b="1" spc="150" kern="0" dirty="0">
                 <a:solidFill>
-                  <a:schemeClr val="tx2"/>
+                  <a:schemeClr val="tx1"/>
                 </a:solidFill>
               </a:defRPr>
             </a:lvl1pPr>
@@ -4137,7 +4101,7 @@
             <a:r>
               <a:rPr lang="en-US" sz="1100" b="1" spc="150" kern="0" dirty="0">
                 <a:solidFill>
-                  <a:schemeClr val="tx2"/>
+                  <a:schemeClr val="tx1"/>
                 </a:solidFill>
               </a:rPr>
               <a:t>SECTION</a:t>
@@ -4340,7 +4304,7 @@
             </a:avLst>
           </a:prstGeom>
           <a:solidFill>
-            <a:srgbClr val="EAF1F6"/>
+            <a:srgbClr val="E7F1FB"/>
           </a:solidFill>
           <a:ln/>
         </p:spPr>
@@ -4555,7 +4519,7 @@
             </a:avLst>
           </a:prstGeom>
           <a:solidFill>
-            <a:srgbClr val="E9C46A"/>
+            <a:srgbClr val="F4B223"/>
           </a:solidFill>
           <a:ln/>
         </p:spPr>
@@ -4596,7 +4560,7 @@
               <a:buNone/>
               <a:defRPr lang="en-US" sz="1100" b="1" spc="150" kern="0" dirty="0">
                 <a:solidFill>
-                  <a:schemeClr val="tx2"/>
+                  <a:schemeClr val="tx1"/>
                 </a:solidFill>
               </a:defRPr>
             </a:lvl1pPr>
@@ -4608,7 +4572,7 @@
             <a:r>
               <a:rPr lang="en-US" sz="1100" b="1" spc="150" kern="0" dirty="0">
                 <a:solidFill>
-                  <a:schemeClr val="tx2"/>
+                  <a:schemeClr val="tx1"/>
                 </a:solidFill>
               </a:rPr>
               <a:t>SECTION</a:t>
@@ -4717,7 +4681,7 @@
             </a:avLst>
           </a:prstGeom>
           <a:solidFill>
-            <a:srgbClr val="EAF1F6"/>
+            <a:srgbClr val="E7F1FB"/>
           </a:solidFill>
           <a:ln/>
         </p:spPr>
@@ -4849,7 +4813,7 @@
             </a:avLst>
           </a:prstGeom>
           <a:solidFill>
-            <a:srgbClr val="EAF1F6"/>
+            <a:srgbClr val="E7F1FB"/>
           </a:solidFill>
           <a:ln/>
         </p:spPr>
@@ -4981,7 +4945,7 @@
             </a:avLst>
           </a:prstGeom>
           <a:solidFill>
-            <a:srgbClr val="EAF1F6"/>
+            <a:srgbClr val="E7F1FB"/>
           </a:solidFill>
           <a:ln/>
         </p:spPr>
@@ -5113,7 +5077,7 @@
             </a:avLst>
           </a:prstGeom>
           <a:solidFill>
-            <a:srgbClr val="FBF3DC"/>
+            <a:srgbClr val="FCE9F2"/>
           </a:solidFill>
           <a:ln/>
         </p:spPr>
@@ -5269,7 +5233,7 @@
             </a:avLst>
           </a:prstGeom>
           <a:solidFill>
-            <a:srgbClr val="E9C46A"/>
+            <a:srgbClr val="F4B223"/>
           </a:solidFill>
           <a:ln/>
         </p:spPr>
@@ -5310,7 +5274,7 @@
               <a:buNone/>
               <a:defRPr lang="en-US" sz="1100" b="1" spc="150" kern="0" dirty="0">
                 <a:solidFill>
-                  <a:schemeClr val="tx2"/>
+                  <a:schemeClr val="tx1"/>
                 </a:solidFill>
               </a:defRPr>
             </a:lvl1pPr>
@@ -5322,7 +5286,7 @@
             <a:r>
               <a:rPr lang="en-US" sz="1100" b="1" spc="150" kern="0" dirty="0">
                 <a:solidFill>
-                  <a:schemeClr val="tx2"/>
+                  <a:schemeClr val="tx1"/>
                 </a:solidFill>
               </a:rPr>
               <a:t>SECTION</a:t>
@@ -5431,7 +5395,7 @@
             </a:avLst>
           </a:prstGeom>
           <a:solidFill>
-            <a:srgbClr val="EAF1F6"/>
+            <a:srgbClr val="E7F1FB"/>
           </a:solidFill>
           <a:ln/>
         </p:spPr>
@@ -5461,7 +5425,7 @@
             <a:avLst/>
           </a:prstGeom>
           <a:solidFill>
-            <a:srgbClr val="E9C46A"/>
+            <a:srgbClr val="F4B223"/>
           </a:solidFill>
           <a:ln/>
         </p:spPr>
@@ -5599,7 +5563,7 @@
             </a:avLst>
           </a:prstGeom>
           <a:solidFill>
-            <a:srgbClr val="EAF1F6"/>
+            <a:srgbClr val="E7F1FB"/>
           </a:solidFill>
           <a:ln/>
         </p:spPr>
@@ -5629,7 +5593,7 @@
             <a:avLst/>
           </a:prstGeom>
           <a:solidFill>
-            <a:srgbClr val="E9C46A"/>
+            <a:srgbClr val="F4B223"/>
           </a:solidFill>
           <a:ln/>
         </p:spPr>
@@ -5844,7 +5808,7 @@
             </a:avLst>
           </a:prstGeom>
           <a:solidFill>
-            <a:srgbClr val="E9C46A"/>
+            <a:srgbClr val="F4B223"/>
           </a:solidFill>
           <a:ln/>
         </p:spPr>
@@ -5885,7 +5849,7 @@
               <a:buNone/>
               <a:defRPr lang="en-US" sz="1100" b="1" spc="150" kern="0" dirty="0">
                 <a:solidFill>
-                  <a:schemeClr val="tx2"/>
+                  <a:schemeClr val="tx1"/>
                 </a:solidFill>
               </a:defRPr>
             </a:lvl1pPr>
@@ -5897,7 +5861,7 @@
             <a:r>
               <a:rPr lang="en-US" sz="1100" b="1" spc="150" kern="0" dirty="0">
                 <a:solidFill>
-                  <a:schemeClr val="tx2"/>
+                  <a:schemeClr val="tx1"/>
                 </a:solidFill>
               </a:rPr>
               <a:t>SECTION</a:t>
@@ -6006,7 +5970,7 @@
             </a:avLst>
           </a:prstGeom>
           <a:solidFill>
-            <a:srgbClr val="EAF1F6"/>
+            <a:srgbClr val="E7F1FB"/>
           </a:solidFill>
           <a:ln/>
         </p:spPr>
@@ -6036,7 +6000,7 @@
             <a:avLst/>
           </a:prstGeom>
           <a:solidFill>
-            <a:srgbClr val="E9C46A"/>
+            <a:srgbClr val="F4B223"/>
           </a:solidFill>
           <a:ln w="38100">
             <a:solidFill>
@@ -6082,7 +6046,7 @@
             <a:r>
               <a:rPr lang="en-US" sz="2600" b="1" dirty="0">
                 <a:solidFill>
-                  <a:schemeClr val="tx2"/>
+                  <a:schemeClr val="tx1"/>
                 </a:solidFill>
                 <a:latin typeface="Cambria" pitchFamily="34" charset="0"/>
                 <a:ea typeface="Cambria" pitchFamily="34" charset="-122"/>
@@ -6247,7 +6211,7 @@
             </a:avLst>
           </a:prstGeom>
           <a:solidFill>
-            <a:srgbClr val="EAF1F6"/>
+            <a:srgbClr val="E7F1FB"/>
           </a:solidFill>
           <a:ln/>
         </p:spPr>
@@ -6277,7 +6241,7 @@
             <a:avLst/>
           </a:prstGeom>
           <a:solidFill>
-            <a:srgbClr val="E9C46A"/>
+            <a:srgbClr val="F4B223"/>
           </a:solidFill>
           <a:ln w="38100">
             <a:solidFill>
@@ -6323,7 +6287,7 @@
             <a:r>
               <a:rPr lang="en-US" sz="2600" b="1" dirty="0">
                 <a:solidFill>
-                  <a:schemeClr val="tx2"/>
+                  <a:schemeClr val="tx1"/>
                 </a:solidFill>
                 <a:latin typeface="Cambria" pitchFamily="34" charset="0"/>
                 <a:ea typeface="Cambria" pitchFamily="34" charset="-122"/>
@@ -6488,7 +6452,7 @@
             </a:avLst>
           </a:prstGeom>
           <a:solidFill>
-            <a:srgbClr val="EAF1F6"/>
+            <a:srgbClr val="E7F1FB"/>
           </a:solidFill>
           <a:ln/>
         </p:spPr>
@@ -6518,7 +6482,7 @@
             <a:avLst/>
           </a:prstGeom>
           <a:solidFill>
-            <a:srgbClr val="E9C46A"/>
+            <a:srgbClr val="F4B223"/>
           </a:solidFill>
           <a:ln w="38100">
             <a:solidFill>
@@ -6564,7 +6528,7 @@
             <a:r>
               <a:rPr lang="en-US" sz="2600" b="1" dirty="0">
                 <a:solidFill>
-                  <a:schemeClr val="tx2"/>
+                  <a:schemeClr val="tx1"/>
                 </a:solidFill>
                 <a:latin typeface="Cambria" pitchFamily="34" charset="0"/>
                 <a:ea typeface="Cambria" pitchFamily="34" charset="-122"/>
@@ -6729,7 +6693,7 @@
             </a:avLst>
           </a:prstGeom>
           <a:solidFill>
-            <a:srgbClr val="EAF1F6"/>
+            <a:srgbClr val="E7F1FB"/>
           </a:solidFill>
           <a:ln/>
         </p:spPr>
@@ -6759,7 +6723,7 @@
             <a:avLst/>
           </a:prstGeom>
           <a:solidFill>
-            <a:srgbClr val="E9C46A"/>
+            <a:srgbClr val="F4B223"/>
           </a:solidFill>
           <a:ln w="38100">
             <a:solidFill>
@@ -6805,7 +6769,7 @@
             <a:r>
               <a:rPr lang="en-US" sz="2600" b="1" dirty="0">
                 <a:solidFill>
-                  <a:schemeClr val="tx2"/>
+                  <a:schemeClr val="tx1"/>
                 </a:solidFill>
                 <a:latin typeface="Cambria" pitchFamily="34" charset="0"/>
                 <a:ea typeface="Cambria" pitchFamily="34" charset="-122"/>
@@ -7011,7 +6975,7 @@
             </a:avLst>
           </a:prstGeom>
           <a:solidFill>
-            <a:srgbClr val="E9C46A"/>
+            <a:srgbClr val="F4B223"/>
           </a:solidFill>
           <a:ln/>
         </p:spPr>
@@ -7052,7 +7016,7 @@
               <a:buNone/>
               <a:defRPr lang="en-US" sz="1100" b="1" spc="150" kern="0" dirty="0">
                 <a:solidFill>
-                  <a:schemeClr val="tx2"/>
+                  <a:schemeClr val="tx1"/>
                 </a:solidFill>
               </a:defRPr>
             </a:lvl1pPr>
@@ -7064,7 +7028,7 @@
             <a:r>
               <a:rPr lang="en-US" sz="1100" b="1" spc="150" kern="0" dirty="0">
                 <a:solidFill>
-                  <a:schemeClr val="tx2"/>
+                  <a:schemeClr val="tx1"/>
                 </a:solidFill>
               </a:rPr>
               <a:t>SECTION</a:t>
@@ -7332,7 +7296,7 @@
         </p:nvSpPr>
         <p:spPr>
           <a:xfrm>
-            <a:off x="11094415" y="6400800"/>
+            <a:off x="11094415" y="365760"/>
             <a:ext cx="548640" cy="274320"/>
           </a:xfrm>
           <a:prstGeom prst="rect">
@@ -7350,7 +7314,7 @@
             <a:lvl1pPr>
               <a:defRPr sz="1000">
                 <a:solidFill>
-                  <a:srgbClr val="E9C46A"/>
+                  <a:srgbClr val="FFFFFF"/>
                 </a:solidFill>
               </a:defRPr>
             </a:lvl1pPr>
@@ -7663,7 +7627,7 @@
         <p:spPr>
           <a:xfrm>
             <a:off x="731520" y="1554480"/>
-            <a:ext cx="8686800" cy="1645920"/>
+            <a:ext cx="7223760" cy="1645920"/>
           </a:xfrm>
           <a:prstGeom prst="rect">
             <a:avLst/>
@@ -7693,7 +7657,7 @@
         <p:spPr>
           <a:xfrm>
             <a:off x="731520" y="3337560"/>
-            <a:ext cx="8686800" cy="548640"/>
+            <a:ext cx="7223760" cy="548640"/>
           </a:xfrm>
           <a:prstGeom prst="rect">
             <a:avLst/>
@@ -7723,7 +7687,7 @@
         <p:spPr>
           <a:xfrm>
             <a:off x="731520" y="4206240"/>
-            <a:ext cx="8686800" cy="731520"/>
+            <a:ext cx="7223760" cy="731520"/>
           </a:xfrm>
           <a:prstGeom prst="rect">
             <a:avLst/>
@@ -8375,7 +8339,7 @@
         </p:nvSpPr>
         <p:spPr>
           <a:xfrm>
-            <a:off x="11094415" y="6400800"/>
+            <a:off x="11094415" y="365760"/>
             <a:ext cx="548640" cy="274320"/>
           </a:xfrm>
           <a:prstGeom prst="rect">
@@ -8393,7 +8357,7 @@
             <a:lvl1pPr>
               <a:defRPr sz="1000">
                 <a:solidFill>
-                  <a:srgbClr val="E9C46A"/>
+                  <a:srgbClr val="FFFFFF"/>
                 </a:solidFill>
               </a:defRPr>
             </a:lvl1pPr>
@@ -9770,7 +9734,7 @@
         </p:nvSpPr>
         <p:spPr>
           <a:xfrm>
-            <a:off x="11094415" y="6400800"/>
+            <a:off x="11094415" y="365760"/>
             <a:ext cx="548640" cy="274320"/>
           </a:xfrm>
           <a:prstGeom prst="rect">
@@ -9788,7 +9752,7 @@
             <a:lvl1pPr>
               <a:defRPr sz="1000">
                 <a:solidFill>
-                  <a:srgbClr val="E9C46A"/>
+                  <a:srgbClr val="FFFFFF"/>
                 </a:solidFill>
               </a:defRPr>
             </a:lvl1pPr>
@@ -9930,7 +9894,7 @@
         </p:nvSpPr>
         <p:spPr>
           <a:xfrm>
-            <a:off x="11094415" y="6400800"/>
+            <a:off x="11094415" y="365760"/>
             <a:ext cx="548640" cy="274320"/>
           </a:xfrm>
           <a:prstGeom prst="rect">
@@ -9948,7 +9912,7 @@
             <a:lvl1pPr>
               <a:defRPr sz="1000">
                 <a:solidFill>
-                  <a:srgbClr val="E9C46A"/>
+                  <a:srgbClr val="FFFFFF"/>
                 </a:solidFill>
               </a:defRPr>
             </a:lvl1pPr>
@@ -11486,7 +11450,7 @@
         </p:nvSpPr>
         <p:spPr>
           <a:xfrm>
-            <a:off x="11094415" y="6400800"/>
+            <a:off x="11094415" y="365760"/>
             <a:ext cx="548640" cy="274320"/>
           </a:xfrm>
           <a:prstGeom prst="rect">
@@ -11504,7 +11468,7 @@
             <a:lvl1pPr>
               <a:defRPr sz="1000">
                 <a:solidFill>
-                  <a:srgbClr val="E9C46A"/>
+                  <a:srgbClr val="FFFFFF"/>
                 </a:solidFill>
               </a:defRPr>
             </a:lvl1pPr>
@@ -12934,47 +12898,47 @@
 </file>
 
 <file path=ppt/theme/theme1.xml><?xml version="1.0" encoding="utf-8"?>
-<a:theme xmlns:a="http://schemas.openxmlformats.org/drawingml/2006/main" name="Ocean and Sand">
+<a:theme xmlns:a="http://schemas.openxmlformats.org/drawingml/2006/main" name="Mural">
   <a:themeElements>
-    <a:clrScheme name="Ocean and Sand">
+    <a:clrScheme name="Mural">
       <a:dk1>
-        <a:srgbClr val="072B45"/>
+        <a:srgbClr val="16151F"/>
       </a:dk1>
       <a:lt1>
         <a:srgbClr val="FFFFFF"/>
       </a:lt1>
       <a:dk2>
-        <a:srgbClr val="0A3D62"/>
+        <a:srgbClr val="0F79D5"/>
       </a:dk2>
       <a:lt2>
-        <a:srgbClr val="EAF1F6"/>
+        <a:srgbClr val="E7F1FB"/>
       </a:lt2>
       <a:accent1>
-        <a:srgbClr val="0A3D62"/>
+        <a:srgbClr val="0F79D5"/>
       </a:accent1>
       <a:accent2>
-        <a:srgbClr val="E9C46A"/>
+        <a:srgbClr val="F4B223"/>
       </a:accent2>
       <a:accent3>
-        <a:srgbClr val="2E7DA6"/>
+        <a:srgbClr val="E0251B"/>
       </a:accent3>
       <a:accent4>
-        <a:srgbClr val="B8902E"/>
+        <a:srgbClr val="E2558F"/>
       </a:accent4>
       <a:accent5>
-        <a:srgbClr val="8FB8D3"/>
+        <a:srgbClr val="2E8B1E"/>
       </a:accent5>
       <a:accent6>
         <a:srgbClr val="5B6B7A"/>
       </a:accent6>
       <a:hlink>
-        <a:srgbClr val="2E7DA6"/>
+        <a:srgbClr val="0F79D5"/>
       </a:hlink>
       <a:folHlink>
-        <a:srgbClr val="5B6B7A"/>
+        <a:srgbClr val="E2558F"/>
       </a:folHlink>
     </a:clrScheme>
-    <a:fontScheme name="Ocean and Sand">
+    <a:fontScheme name="Mural">
       <a:majorFont>
         <a:latin typeface="Cambria"/>
         <a:ea typeface=""/>

</xml_diff>